<commit_message>
Update title slide details on the star apple deck
Co-Authored-By: Claude Opus 5.5 <noreply@anthropic.com>
Claude-Session: https://claude.ai/code/session_01LRgAywWUpAqV5tRHALsb91
</commit_message>
<xml_diff>
--- a/thesis-presentations/African_Star_Apple_Seed_Oil_RSM.pptx
+++ b/thesis-presentations/African_Star_Apple_Seed_Oil_RSM.pptx
@@ -2289,7 +2289,7 @@
                 <a:ea typeface="Cambria" pitchFamily="34" charset="-122"/>
                 <a:cs typeface="Cambria" pitchFamily="34" charset="-120"/>
               </a:rPr>
-              <a:t>Effect of Oven Thermal Pretreatment on the Oil Yield of African Star Apple Seeds Using Response Surface Methodology</a:t>
+              <a:t>The Effect of Pretreatment on the Oil Yield of African Star Apple</a:t>
             </a:r>
             <a:endParaRPr lang="en-US" sz="2600" dirty="0"/>
           </a:p>
@@ -2331,7 +2331,7 @@
                 <a:ea typeface="Calibri" pitchFamily="34" charset="-122"/>
                 <a:cs typeface="Calibri" pitchFamily="34" charset="-120"/>
               </a:rPr>
-              <a:t>Udedeh Wisdom Aniefiok</a:t>
+              <a:t>Udedeh, Wisdom Aniefiok</a:t>
             </a:r>
             <a:endParaRPr lang="en-US" sz="1700" dirty="0"/>
           </a:p>
@@ -2352,6 +2352,26 @@
                 <a:cs typeface="Calibri" pitchFamily="34" charset="-120"/>
               </a:rPr>
               <a:t>20/EG/AE/705</a:t>
+            </a:r>
+            <a:endParaRPr lang="en-US" sz="1700" dirty="0"/>
+          </a:p>
+          <a:p>
+            <a:pPr algn="ctr" indent="0" marL="0">
+              <a:spcAft>
+                <a:spcPts val="400"/>
+              </a:spcAft>
+              <a:buNone/>
+            </a:pPr>
+            <a:r>
+              <a:rPr lang="en-US" sz="1400" dirty="0">
+                <a:solidFill>
+                  <a:srgbClr val="222222"/>
+                </a:solidFill>
+                <a:latin typeface="Calibri" pitchFamily="34" charset="0"/>
+                <a:ea typeface="Calibri" pitchFamily="34" charset="-122"/>
+                <a:cs typeface="Calibri" pitchFamily="34" charset="-120"/>
+              </a:rPr>
+              <a:t>Agricultural Engineering</a:t>
             </a:r>
             <a:endParaRPr lang="en-US" sz="1700" dirty="0"/>
           </a:p>
@@ -2428,23 +2448,6 @@
                 <a:cs typeface="Calibri" pitchFamily="34" charset="-120"/>
               </a:rPr>
               <a:t>Faculty of Engineering, University of Uyo</a:t>
-            </a:r>
-            <a:endParaRPr lang="en-US" sz="1300" dirty="0"/>
-          </a:p>
-          <a:p>
-            <a:pPr algn="ctr" indent="0" marL="0">
-              <a:buNone/>
-            </a:pPr>
-            <a:r>
-              <a:rPr lang="en-US" sz="1300" dirty="0">
-                <a:solidFill>
-                  <a:srgbClr val="666666"/>
-                </a:solidFill>
-                <a:latin typeface="Calibri" pitchFamily="34" charset="0"/>
-                <a:ea typeface="Calibri" pitchFamily="34" charset="-122"/>
-                <a:cs typeface="Calibri" pitchFamily="34" charset="-120"/>
-              </a:rPr>
-              <a:t>September 2026</a:t>
             </a:r>
             <a:endParaRPr lang="en-US" sz="1300" dirty="0"/>
           </a:p>
@@ -2554,7 +2557,7 @@
                 <a:ea typeface="Calibri" pitchFamily="34" charset="-122"/>
                 <a:cs typeface="Calibri" pitchFamily="34" charset="-120"/>
               </a:rPr>
-              <a:t>Udedeh Wisdom Aniefiok · Oven pretreatment and oil yield of African star apple seeds</a:t>
+              <a:t>Udedeh, Wisdom Aniefiok · Effect of pretreatment on the oil yield of African star apple</a:t>
             </a:r>
             <a:endParaRPr lang="en-US" sz="900" dirty="0"/>
           </a:p>
@@ -4383,7 +4386,7 @@
                 <a:ea typeface="Calibri" pitchFamily="34" charset="-122"/>
                 <a:cs typeface="Calibri" pitchFamily="34" charset="-120"/>
               </a:rPr>
-              <a:t>Udedeh Wisdom Aniefiok · Oven pretreatment and oil yield of African star apple seeds</a:t>
+              <a:t>Udedeh, Wisdom Aniefiok · Effect of pretreatment on the oil yield of African star apple</a:t>
             </a:r>
             <a:endParaRPr lang="en-US" sz="900" dirty="0"/>
           </a:p>
@@ -4659,7 +4662,7 @@
                 <a:ea typeface="Calibri" pitchFamily="34" charset="-122"/>
                 <a:cs typeface="Calibri" pitchFamily="34" charset="-120"/>
               </a:rPr>
-              <a:t>Udedeh Wisdom Aniefiok · Oven pretreatment and oil yield of African star apple seeds</a:t>
+              <a:t>Udedeh, Wisdom Aniefiok · Effect of pretreatment on the oil yield of African star apple</a:t>
             </a:r>
             <a:endParaRPr lang="en-US" sz="900" dirty="0"/>
           </a:p>
@@ -5141,7 +5144,7 @@
                 <a:ea typeface="Calibri" pitchFamily="34" charset="-122"/>
                 <a:cs typeface="Calibri" pitchFamily="34" charset="-120"/>
               </a:rPr>
-              <a:t>Udedeh Wisdom Aniefiok · Oven pretreatment and oil yield of African star apple seeds</a:t>
+              <a:t>Udedeh, Wisdom Aniefiok · Effect of pretreatment on the oil yield of African star apple</a:t>
             </a:r>
             <a:endParaRPr lang="en-US" sz="900" dirty="0"/>
           </a:p>
@@ -5480,7 +5483,7 @@
                 <a:ea typeface="Calibri" pitchFamily="34" charset="-122"/>
                 <a:cs typeface="Calibri" pitchFamily="34" charset="-120"/>
               </a:rPr>
-              <a:t>Udedeh Wisdom Aniefiok · Oven pretreatment and oil yield of African star apple seeds</a:t>
+              <a:t>Udedeh, Wisdom Aniefiok · Effect of pretreatment on the oil yield of African star apple</a:t>
             </a:r>
             <a:endParaRPr lang="en-US" sz="900" dirty="0"/>
           </a:p>
@@ -5860,7 +5863,7 @@
                 <a:ea typeface="Calibri" pitchFamily="34" charset="-122"/>
                 <a:cs typeface="Calibri" pitchFamily="34" charset="-120"/>
               </a:rPr>
-              <a:t>Udedeh Wisdom Aniefiok · Oven pretreatment and oil yield of African star apple seeds</a:t>
+              <a:t>Udedeh, Wisdom Aniefiok · Effect of pretreatment on the oil yield of African star apple</a:t>
             </a:r>
             <a:endParaRPr lang="en-US" sz="900" dirty="0"/>
           </a:p>
@@ -6322,7 +6325,7 @@
                 <a:ea typeface="Calibri" pitchFamily="34" charset="-122"/>
                 <a:cs typeface="Calibri" pitchFamily="34" charset="-120"/>
               </a:rPr>
-              <a:t>Udedeh Wisdom Aniefiok · Oven pretreatment and oil yield of African star apple seeds</a:t>
+              <a:t>Udedeh, Wisdom Aniefiok · Effect of pretreatment on the oil yield of African star apple</a:t>
             </a:r>
             <a:endParaRPr lang="en-US" sz="900" dirty="0"/>
           </a:p>
@@ -7585,7 +7588,7 @@
                 <a:ea typeface="Calibri" pitchFamily="34" charset="-122"/>
                 <a:cs typeface="Calibri" pitchFamily="34" charset="-120"/>
               </a:rPr>
-              <a:t>Udedeh Wisdom Aniefiok · Oven pretreatment and oil yield of African star apple seeds</a:t>
+              <a:t>Udedeh, Wisdom Aniefiok · Effect of pretreatment on the oil yield of African star apple</a:t>
             </a:r>
             <a:endParaRPr lang="en-US" sz="900" dirty="0"/>
           </a:p>
@@ -7856,7 +7859,7 @@
                 <a:ea typeface="Calibri" pitchFamily="34" charset="-122"/>
                 <a:cs typeface="Calibri" pitchFamily="34" charset="-120"/>
               </a:rPr>
-              <a:t>Udedeh Wisdom Aniefiok · Oven pretreatment and oil yield of African star apple seeds</a:t>
+              <a:t>Udedeh, Wisdom Aniefiok · Effect of pretreatment on the oil yield of African star apple</a:t>
             </a:r>
             <a:endParaRPr lang="en-US" sz="900" dirty="0"/>
           </a:p>
@@ -10272,7 +10275,7 @@
                 <a:ea typeface="Calibri" pitchFamily="34" charset="-122"/>
                 <a:cs typeface="Calibri" pitchFamily="34" charset="-120"/>
               </a:rPr>
-              <a:t>Udedeh Wisdom Aniefiok · Oven pretreatment and oil yield of African star apple seeds</a:t>
+              <a:t>Udedeh, Wisdom Aniefiok · Effect of pretreatment on the oil yield of African star apple</a:t>
             </a:r>
             <a:endParaRPr lang="en-US" sz="900" dirty="0"/>
           </a:p>
@@ -10590,7 +10593,7 @@
                 <a:ea typeface="Calibri" pitchFamily="34" charset="-122"/>
                 <a:cs typeface="Calibri" pitchFamily="34" charset="-120"/>
               </a:rPr>
-              <a:t>Udedeh Wisdom Aniefiok · Oven pretreatment and oil yield of African star apple seeds</a:t>
+              <a:t>Udedeh, Wisdom Aniefiok · Effect of pretreatment on the oil yield of African star apple</a:t>
             </a:r>
             <a:endParaRPr lang="en-US" sz="900" dirty="0"/>
           </a:p>

</xml_diff>

<commit_message>
Use the full thesis title on the star apple deck
Co-Authored-By: Claude Opus 5.5 <noreply@anthropic.com>
Claude-Session: https://claude.ai/code/session_01LRgAywWUpAqV5tRHALsb91
</commit_message>
<xml_diff>
--- a/thesis-presentations/African_Star_Apple_Seed_Oil_RSM.pptx
+++ b/thesis-presentations/African_Star_Apple_Seed_Oil_RSM.pptx
@@ -2289,7 +2289,7 @@
                 <a:ea typeface="Cambria" pitchFamily="34" charset="-122"/>
                 <a:cs typeface="Cambria" pitchFamily="34" charset="-120"/>
               </a:rPr>
-              <a:t>The Effect of Pretreatment on the Oil Yield of African Star Apple</a:t>
+              <a:t>Effect of Oven Thermal Pretreatment on the Oil Yield of African Star Apple Seeds Using Response Surface Methodology</a:t>
             </a:r>
             <a:endParaRPr lang="en-US" sz="2600" dirty="0"/>
           </a:p>
@@ -2557,7 +2557,7 @@
                 <a:ea typeface="Calibri" pitchFamily="34" charset="-122"/>
                 <a:cs typeface="Calibri" pitchFamily="34" charset="-120"/>
               </a:rPr>
-              <a:t>Udedeh, Wisdom Aniefiok · Effect of pretreatment on the oil yield of African star apple</a:t>
+              <a:t>Udedeh, Wisdom Aniefiok · Effect of oven thermal pretreatment on the oil yield of African star apple seeds</a:t>
             </a:r>
             <a:endParaRPr lang="en-US" sz="900" dirty="0"/>
           </a:p>
@@ -4386,7 +4386,7 @@
                 <a:ea typeface="Calibri" pitchFamily="34" charset="-122"/>
                 <a:cs typeface="Calibri" pitchFamily="34" charset="-120"/>
               </a:rPr>
-              <a:t>Udedeh, Wisdom Aniefiok · Effect of pretreatment on the oil yield of African star apple</a:t>
+              <a:t>Udedeh, Wisdom Aniefiok · Effect of oven thermal pretreatment on the oil yield of African star apple seeds</a:t>
             </a:r>
             <a:endParaRPr lang="en-US" sz="900" dirty="0"/>
           </a:p>
@@ -4662,7 +4662,7 @@
                 <a:ea typeface="Calibri" pitchFamily="34" charset="-122"/>
                 <a:cs typeface="Calibri" pitchFamily="34" charset="-120"/>
               </a:rPr>
-              <a:t>Udedeh, Wisdom Aniefiok · Effect of pretreatment on the oil yield of African star apple</a:t>
+              <a:t>Udedeh, Wisdom Aniefiok · Effect of oven thermal pretreatment on the oil yield of African star apple seeds</a:t>
             </a:r>
             <a:endParaRPr lang="en-US" sz="900" dirty="0"/>
           </a:p>
@@ -5144,7 +5144,7 @@
                 <a:ea typeface="Calibri" pitchFamily="34" charset="-122"/>
                 <a:cs typeface="Calibri" pitchFamily="34" charset="-120"/>
               </a:rPr>
-              <a:t>Udedeh, Wisdom Aniefiok · Effect of pretreatment on the oil yield of African star apple</a:t>
+              <a:t>Udedeh, Wisdom Aniefiok · Effect of oven thermal pretreatment on the oil yield of African star apple seeds</a:t>
             </a:r>
             <a:endParaRPr lang="en-US" sz="900" dirty="0"/>
           </a:p>
@@ -5483,7 +5483,7 @@
                 <a:ea typeface="Calibri" pitchFamily="34" charset="-122"/>
                 <a:cs typeface="Calibri" pitchFamily="34" charset="-120"/>
               </a:rPr>
-              <a:t>Udedeh, Wisdom Aniefiok · Effect of pretreatment on the oil yield of African star apple</a:t>
+              <a:t>Udedeh, Wisdom Aniefiok · Effect of oven thermal pretreatment on the oil yield of African star apple seeds</a:t>
             </a:r>
             <a:endParaRPr lang="en-US" sz="900" dirty="0"/>
           </a:p>
@@ -5863,7 +5863,7 @@
                 <a:ea typeface="Calibri" pitchFamily="34" charset="-122"/>
                 <a:cs typeface="Calibri" pitchFamily="34" charset="-120"/>
               </a:rPr>
-              <a:t>Udedeh, Wisdom Aniefiok · Effect of pretreatment on the oil yield of African star apple</a:t>
+              <a:t>Udedeh, Wisdom Aniefiok · Effect of oven thermal pretreatment on the oil yield of African star apple seeds</a:t>
             </a:r>
             <a:endParaRPr lang="en-US" sz="900" dirty="0"/>
           </a:p>
@@ -6325,7 +6325,7 @@
                 <a:ea typeface="Calibri" pitchFamily="34" charset="-122"/>
                 <a:cs typeface="Calibri" pitchFamily="34" charset="-120"/>
               </a:rPr>
-              <a:t>Udedeh, Wisdom Aniefiok · Effect of pretreatment on the oil yield of African star apple</a:t>
+              <a:t>Udedeh, Wisdom Aniefiok · Effect of oven thermal pretreatment on the oil yield of African star apple seeds</a:t>
             </a:r>
             <a:endParaRPr lang="en-US" sz="900" dirty="0"/>
           </a:p>
@@ -7588,7 +7588,7 @@
                 <a:ea typeface="Calibri" pitchFamily="34" charset="-122"/>
                 <a:cs typeface="Calibri" pitchFamily="34" charset="-120"/>
               </a:rPr>
-              <a:t>Udedeh, Wisdom Aniefiok · Effect of pretreatment on the oil yield of African star apple</a:t>
+              <a:t>Udedeh, Wisdom Aniefiok · Effect of oven thermal pretreatment on the oil yield of African star apple seeds</a:t>
             </a:r>
             <a:endParaRPr lang="en-US" sz="900" dirty="0"/>
           </a:p>
@@ -7859,7 +7859,7 @@
                 <a:ea typeface="Calibri" pitchFamily="34" charset="-122"/>
                 <a:cs typeface="Calibri" pitchFamily="34" charset="-120"/>
               </a:rPr>
-              <a:t>Udedeh, Wisdom Aniefiok · Effect of pretreatment on the oil yield of African star apple</a:t>
+              <a:t>Udedeh, Wisdom Aniefiok · Effect of oven thermal pretreatment on the oil yield of African star apple seeds</a:t>
             </a:r>
             <a:endParaRPr lang="en-US" sz="900" dirty="0"/>
           </a:p>
@@ -10275,7 +10275,7 @@
                 <a:ea typeface="Calibri" pitchFamily="34" charset="-122"/>
                 <a:cs typeface="Calibri" pitchFamily="34" charset="-120"/>
               </a:rPr>
-              <a:t>Udedeh, Wisdom Aniefiok · Effect of pretreatment on the oil yield of African star apple</a:t>
+              <a:t>Udedeh, Wisdom Aniefiok · Effect of oven thermal pretreatment on the oil yield of African star apple seeds</a:t>
             </a:r>
             <a:endParaRPr lang="en-US" sz="900" dirty="0"/>
           </a:p>
@@ -10593,7 +10593,7 @@
                 <a:ea typeface="Calibri" pitchFamily="34" charset="-122"/>
                 <a:cs typeface="Calibri" pitchFamily="34" charset="-120"/>
               </a:rPr>
-              <a:t>Udedeh, Wisdom Aniefiok · Effect of pretreatment on the oil yield of African star apple</a:t>
+              <a:t>Udedeh, Wisdom Aniefiok · Effect of oven thermal pretreatment on the oil yield of African star apple seeds</a:t>
             </a:r>
             <a:endParaRPr lang="en-US" sz="900" dirty="0"/>
           </a:p>

</xml_diff>

<commit_message>
Add September, 2026 to both title slides
Co-Authored-By: Claude Opus 5.5 <noreply@anthropic.com>
Claude-Session: https://claude.ai/code/session_01LRgAywWUpAqV5tRHALsb91
</commit_message>
<xml_diff>
--- a/thesis-presentations/African_Star_Apple_Seed_Oil_RSM.pptx
+++ b/thesis-presentations/African_Star_Apple_Seed_Oil_RSM.pptx
@@ -2451,6 +2451,23 @@
             </a:r>
             <a:endParaRPr lang="en-US" sz="1300" dirty="0"/>
           </a:p>
+          <a:p>
+            <a:pPr algn="ctr" indent="0" marL="0">
+              <a:buNone/>
+            </a:pPr>
+            <a:r>
+              <a:rPr lang="en-US" sz="1300" dirty="0">
+                <a:solidFill>
+                  <a:srgbClr val="666666"/>
+                </a:solidFill>
+                <a:latin typeface="Calibri" pitchFamily="34" charset="0"/>
+                <a:ea typeface="Calibri" pitchFamily="34" charset="-122"/>
+                <a:cs typeface="Calibri" pitchFamily="34" charset="-120"/>
+              </a:rPr>
+              <a:t>September, 2026</a:t>
+            </a:r>
+            <a:endParaRPr lang="en-US" sz="1300" dirty="0"/>
+          </a:p>
         </p:txBody>
       </p:sp>
     </p:spTree>

</xml_diff>